<commit_message>
TL00 Sim-Review: 8 VPs eingearbeitet + sim_review true
Workshop-Simulation TL00 (3 Teamleiter-Personas), 8 VPs (3 Hoch/4 Mittel/
1 Niedrig) umgesetzt: AB-1 Teil 4 vierte Rollenfalle + Teil 2 Ausfuellhilfe,
Sec 3.3 zwei neue Reaktionsbloecke (Rollen-Ambivalenz, Autoritaet ohne
Vertrauen), Musterloesung Situation A Uebergabe-Formulierung, Sechs-Schritte-
Kurzformat als Tisch-Handout, AB-2 Erwartete-Reaktion-Leitfrage, Timing
AB-2 30->25/Abschluss 15->20 + TL01/02/04-Anschlussverweise, YAML Regie-Hinweis.
Workbook/Trainerhandbuch/Deck neu, Validator 0/0.

Co-Authored-By: Claude Opus 4.8 <noreply@anthropic.com>
</commit_message>
<xml_diff>
--- a/protected-downloads/praesentation/TL00.pptx
+++ b/protected-downloads/praesentation/TL00.pptx
@@ -590,6 +590,11 @@
         <p:txBody>
           <a:bodyPr/>
           <a:lstStyle/>
+          <a:p>
+            <a:r>
+              <a:t>REGIE-HINWEIS zur Reihenfolge: Die Methoden-Einführung Kollegiale Fallberatung (Sechs-Schritte, Block V) kommt laut Ablaufplan Sec 3.1 VOR diesem Fall (10:35–10:45). Die Fallberatungs-Folien folgen im Deck erst danach, damit der Thomas-K.-Fall die Methode motiviert – die kurze Flipchart-Einführung selbst erfolgt aber bereits vor diesem Block.</a:t>
+            </a:r>
+          </a:p>
           <a:p>
             <a:r>
               <a:t>Ausgangslage laut vorlesen – gemeinsame Szene schaffen. Situationen gezielt verteilen: B2 immer der erfahrensten Gruppe oder ans Plenum.</a:t>
@@ -10853,7 +10858,7 @@
                 </a:solidFill>
                 <a:latin typeface="Consolas"/>
               </a:rPr>
-              <a:t>12:15–12:45 (30 Min.)</a:t>
+              <a:t>12:15–12:40 (25 Min.)</a:t>
             </a:r>
             <a:r>
               <a:rPr sz="1200" b="1">
@@ -10890,7 +10895,7 @@
                 </a:solidFill>
                 <a:latin typeface="Consolas"/>
               </a:rPr>
-              <a:t>12:45–13:00 (15 Min.)</a:t>
+              <a:t>12:40–13:00 (20 Min.)</a:t>
             </a:r>
             <a:r>
               <a:rPr sz="1200" b="1">

</xml_diff>